<commit_message>
Edit slides 4-6 of the Oct 21 presentation deck
Retitle slide 4 to "PC–STM32–Flash 데이터플로우" and label the
firmware block "Firmware", capitalize "Double Buffer" on slide 5, and
drop "올림" from the 3,145,782 ÷ 256 page-count note on slide 6.

Co-Authored-By: Claude Opus 5.5 <noreply@anthropic.com>
</commit_message>
<xml_diff>
--- a/presentation_oct20/output/UART_SPIFlash_2차발표_1021.pptx
+++ b/presentation_oct20/output/UART_SPIFlash_2차발표_1021.pptx
@@ -1758,7 +1758,7 @@
           </a:prstGeom>
           <a:extLst>
             <a:ext uri="{C572A759-6A51-4108-AA02-DFA0A04FC94B}">
-              <ma14:wrappingTextBoxFlag xmlns:ma14="http://schemas.microsoft.com/office/mac/drawingml/2011/main" xmlns="" val="0"/>
+              <ma14:wrappingTextBoxFlag xmlns="" xmlns:ma14="http://schemas.microsoft.com/office/mac/drawingml/2011/main" val="0"/>
             </a:ext>
           </a:extLst>
         </p:spPr>
@@ -1836,7 +1836,7 @@
           </a:prstGeom>
           <a:extLst>
             <a:ext uri="{C572A759-6A51-4108-AA02-DFA0A04FC94B}">
-              <ma14:wrappingTextBoxFlag xmlns:ma14="http://schemas.microsoft.com/office/mac/drawingml/2011/main" xmlns="" val="0"/>
+              <ma14:wrappingTextBoxFlag xmlns="" xmlns:ma14="http://schemas.microsoft.com/office/mac/drawingml/2011/main" val="0"/>
             </a:ext>
           </a:extLst>
         </p:spPr>
@@ -3324,7 +3324,7 @@
           </a:prstGeom>
           <a:extLst>
             <a:ext uri="{C572A759-6A51-4108-AA02-DFA0A04FC94B}">
-              <ma14:wrappingTextBoxFlag xmlns:ma14="http://schemas.microsoft.com/office/mac/drawingml/2011/main" xmlns="" val="0"/>
+              <ma14:wrappingTextBoxFlag xmlns="" xmlns:ma14="http://schemas.microsoft.com/office/mac/drawingml/2011/main" val="0"/>
             </a:ext>
           </a:extLst>
         </p:spPr>
@@ -4707,7 +4707,7 @@
           </a:prstGeom>
           <a:extLst>
             <a:ext uri="{C572A759-6A51-4108-AA02-DFA0A04FC94B}">
-              <ma14:wrappingTextBoxFlag xmlns:ma14="http://schemas.microsoft.com/office/mac/drawingml/2011/main" xmlns="" val="0"/>
+              <ma14:wrappingTextBoxFlag xmlns="" xmlns:ma14="http://schemas.microsoft.com/office/mac/drawingml/2011/main" val="0"/>
             </a:ext>
           </a:extLst>
         </p:spPr>
@@ -6000,7 +6000,7 @@
           </a:prstGeom>
           <a:extLst>
             <a:ext uri="{C572A759-6A51-4108-AA02-DFA0A04FC94B}">
-              <ma14:wrappingTextBoxFlag xmlns:ma14="http://schemas.microsoft.com/office/mac/drawingml/2011/main" xmlns="" val="0"/>
+              <ma14:wrappingTextBoxFlag xmlns="" xmlns:ma14="http://schemas.microsoft.com/office/mac/drawingml/2011/main" val="0"/>
             </a:ext>
           </a:extLst>
         </p:spPr>
@@ -8499,7 +8499,7 @@
           </a:prstGeom>
           <a:extLst>
             <a:ext uri="{C572A759-6A51-4108-AA02-DFA0A04FC94B}">
-              <ma14:wrappingTextBoxFlag xmlns:ma14="http://schemas.microsoft.com/office/mac/drawingml/2011/main" xmlns="" val="0"/>
+              <ma14:wrappingTextBoxFlag xmlns="" xmlns:ma14="http://schemas.microsoft.com/office/mac/drawingml/2011/main" val="0"/>
             </a:ext>
           </a:extLst>
         </p:spPr>
@@ -11474,7 +11474,7 @@
           </a:prstGeom>
           <a:extLst>
             <a:ext uri="{C572A759-6A51-4108-AA02-DFA0A04FC94B}">
-              <ma14:wrappingTextBoxFlag xmlns:c="http://schemas.openxmlformats.org/drawingml/2006/chart" xmlns:dgm="http://schemas.openxmlformats.org/drawingml/2006/diagram" xmlns:dsp="http://schemas.microsoft.com/office/drawing/2008/diagram" xmlns:ma14="http://schemas.microsoft.com/office/mac/drawingml/2011/main" xmlns="" val="0"/>
+              <ma14:wrappingTextBoxFlag xmlns="" xmlns:ma14="http://schemas.microsoft.com/office/mac/drawingml/2011/main" xmlns:dsp="http://schemas.microsoft.com/office/drawing/2008/diagram" xmlns:dgm="http://schemas.openxmlformats.org/drawingml/2006/diagram" xmlns:c="http://schemas.openxmlformats.org/drawingml/2006/chart" val="0"/>
             </a:ext>
           </a:extLst>
         </p:spPr>
@@ -13584,7 +13584,7 @@
           </a:prstGeom>
           <a:extLst>
             <a:ext uri="{C572A759-6A51-4108-AA02-DFA0A04FC94B}">
-              <ma14:wrappingTextBoxFlag xmlns:c="http://schemas.openxmlformats.org/drawingml/2006/chart" xmlns:dgm="http://schemas.openxmlformats.org/drawingml/2006/diagram" xmlns:dsp="http://schemas.microsoft.com/office/drawing/2008/diagram" xmlns:ma14="http://schemas.microsoft.com/office/mac/drawingml/2011/main" xmlns="" val="0"/>
+              <ma14:wrappingTextBoxFlag xmlns="" xmlns:ma14="http://schemas.microsoft.com/office/mac/drawingml/2011/main" xmlns:dsp="http://schemas.microsoft.com/office/drawing/2008/diagram" xmlns:dgm="http://schemas.openxmlformats.org/drawingml/2006/diagram" xmlns:c="http://schemas.openxmlformats.org/drawingml/2006/chart" val="0"/>
             </a:ext>
           </a:extLst>
         </p:spPr>
@@ -13674,7 +13674,29 @@
                 <a:ea typeface="Malgun Gothic" pitchFamily="34" charset="-122"/>
                 <a:cs typeface="Malgun Gothic" pitchFamily="34" charset="-120"/>
               </a:rPr>
-              <a:t>PC–STM32–Flash 데이터 경로와 검증 지점</a:t>
+              <a:t>PC–STM32–Flash</a:t>
+            </a:r>
+            <a:r>
+              <a:rPr lang="ko-KR" altLang="en-US" sz="2600" b="1" dirty="0">
+                <a:solidFill>
+                  <a:srgbClr val="1F2933"/>
+                </a:solidFill>
+                <a:latin typeface="Malgun Gothic" pitchFamily="34" charset="0"/>
+                <a:ea typeface="Malgun Gothic" pitchFamily="34" charset="-122"/>
+                <a:cs typeface="Malgun Gothic" pitchFamily="34" charset="-120"/>
+              </a:rPr>
+              <a:t> </a:t>
+            </a:r>
+            <a:r>
+              <a:rPr lang="ko-KR" altLang="en-US" sz="2600" b="1" dirty="0" err="1">
+                <a:solidFill>
+                  <a:srgbClr val="1F2933"/>
+                </a:solidFill>
+                <a:latin typeface="Malgun Gothic" pitchFamily="34" charset="0"/>
+                <a:ea typeface="Malgun Gothic" pitchFamily="34" charset="-122"/>
+                <a:cs typeface="Malgun Gothic" pitchFamily="34" charset="-120"/>
+              </a:rPr>
+              <a:t>데이터플로우</a:t>
             </a:r>
             <a:endParaRPr lang="en-US" sz="2600" dirty="0"/>
           </a:p>
@@ -14119,9 +14141,8 @@
                 </a:solidFill>
                 <a:latin typeface="Malgun Gothic" pitchFamily="34" charset="0"/>
                 <a:ea typeface="Malgun Gothic" pitchFamily="34" charset="-122"/>
-                <a:cs typeface="Malgun Gothic" pitchFamily="34" charset="-120"/>
-              </a:rPr>
-              <a:t>펌웨어</a:t>
+              </a:rPr>
+              <a:t>Firmware</a:t>
             </a:r>
             <a:endParaRPr lang="en-US" sz="1600" dirty="0"/>
           </a:p>
@@ -15063,7 +15084,7 @@
           </a:prstGeom>
           <a:extLst>
             <a:ext uri="{C572A759-6A51-4108-AA02-DFA0A04FC94B}">
-              <ma14:wrappingTextBoxFlag xmlns:ma14="http://schemas.microsoft.com/office/mac/drawingml/2011/main" xmlns="" val="0"/>
+              <ma14:wrappingTextBoxFlag xmlns="" xmlns:ma14="http://schemas.microsoft.com/office/mac/drawingml/2011/main" val="0"/>
             </a:ext>
           </a:extLst>
         </p:spPr>
@@ -15153,10 +15174,14 @@
                 <a:ea typeface="Malgun Gothic" pitchFamily="34" charset="-122"/>
                 <a:cs typeface="Malgun Gothic" pitchFamily="34" charset="-120"/>
               </a:rPr>
-              <a:t>UART 수신: 4 KiB DMA double </a:t>
-            </a:r>
-            <a:r>
-              <a:rPr lang="en-US" sz="2600" b="1" dirty="0" err="1">
+              <a:t>UART 수신: 4 KiB DMA </a:t>
+            </a:r>
+            <a:r>
+              <a:rPr lang="en-US" dirty="0"/>
+              <a:t>D</a:t>
+            </a:r>
+            <a:r>
+              <a:rPr lang="en-US" sz="2600" b="1" dirty="0">
                 <a:solidFill>
                   <a:srgbClr val="1F2933"/>
                 </a:solidFill>
@@ -15164,7 +15189,22 @@
                 <a:ea typeface="Malgun Gothic" pitchFamily="34" charset="-122"/>
                 <a:cs typeface="Malgun Gothic" pitchFamily="34" charset="-120"/>
               </a:rPr>
-              <a:t>buffer와</a:t>
+              <a:t>ouble </a:t>
+            </a:r>
+            <a:r>
+              <a:rPr lang="en-US" dirty="0" err="1"/>
+              <a:t>B</a:t>
+            </a:r>
+            <a:r>
+              <a:rPr lang="en-US" sz="2600" b="1" dirty="0" err="1">
+                <a:solidFill>
+                  <a:srgbClr val="1F2933"/>
+                </a:solidFill>
+                <a:latin typeface="Malgun Gothic" pitchFamily="34" charset="0"/>
+                <a:ea typeface="Malgun Gothic" pitchFamily="34" charset="-122"/>
+                <a:cs typeface="Malgun Gothic" pitchFamily="34" charset="-120"/>
+              </a:rPr>
+              <a:t>uffer와</a:t>
             </a:r>
             <a:r>
               <a:rPr lang="en-US" sz="2600" b="1" dirty="0">
@@ -17227,7 +17267,7 @@
           </a:prstGeom>
           <a:extLst>
             <a:ext uri="{C572A759-6A51-4108-AA02-DFA0A04FC94B}">
-              <ma14:wrappingTextBoxFlag xmlns:ma14="http://schemas.microsoft.com/office/mac/drawingml/2011/main" xmlns="" val="0"/>
+              <ma14:wrappingTextBoxFlag xmlns="" xmlns:ma14="http://schemas.microsoft.com/office/mac/drawingml/2011/main" val="0"/>
             </a:ext>
           </a:extLst>
         </p:spPr>
@@ -17909,7 +17949,7 @@
                 <a:ea typeface="Malgun Gothic" pitchFamily="34" charset="-122"/>
                 <a:cs typeface="Malgun Gothic" pitchFamily="34" charset="-120"/>
               </a:rPr>
-              <a:t>(3,145,782 ÷ 256, 올림)</a:t>
+              <a:t>(3,145,782 ÷ 256)</a:t>
             </a:r>
             <a:endParaRPr lang="en-US" sz="1400" dirty="0"/>
           </a:p>
@@ -18238,7 +18278,7 @@
           </a:prstGeom>
           <a:extLst>
             <a:ext uri="{C572A759-6A51-4108-AA02-DFA0A04FC94B}">
-              <ma14:wrappingTextBoxFlag xmlns:ma14="http://schemas.microsoft.com/office/mac/drawingml/2011/main" xmlns="" val="0"/>
+              <ma14:wrappingTextBoxFlag xmlns="" xmlns:ma14="http://schemas.microsoft.com/office/mac/drawingml/2011/main" val="0"/>
             </a:ext>
           </a:extLst>
         </p:spPr>
@@ -19901,7 +19941,7 @@
           </a:prstGeom>
           <a:extLst>
             <a:ext uri="{C572A759-6A51-4108-AA02-DFA0A04FC94B}">
-              <ma14:wrappingTextBoxFlag xmlns:ma14="http://schemas.microsoft.com/office/mac/drawingml/2011/main" xmlns="" val="0"/>
+              <ma14:wrappingTextBoxFlag xmlns="" xmlns:ma14="http://schemas.microsoft.com/office/mac/drawingml/2011/main" val="0"/>
             </a:ext>
           </a:extLst>
         </p:spPr>
@@ -20848,7 +20888,7 @@
           </a:prstGeom>
           <a:extLst>
             <a:ext uri="{C572A759-6A51-4108-AA02-DFA0A04FC94B}">
-              <ma14:wrappingTextBoxFlag xmlns:ma14="http://schemas.microsoft.com/office/mac/drawingml/2011/main" xmlns="" val="0"/>
+              <ma14:wrappingTextBoxFlag xmlns="" xmlns:ma14="http://schemas.microsoft.com/office/mac/drawingml/2011/main" val="0"/>
             </a:ext>
           </a:extLst>
         </p:spPr>
@@ -22199,7 +22239,7 @@
           </a:prstGeom>
           <a:extLst>
             <a:ext uri="{C572A759-6A51-4108-AA02-DFA0A04FC94B}">
-              <ma14:wrappingTextBoxFlag xmlns:ma14="http://schemas.microsoft.com/office/mac/drawingml/2011/main" xmlns="" val="0"/>
+              <ma14:wrappingTextBoxFlag xmlns="" xmlns:ma14="http://schemas.microsoft.com/office/mac/drawingml/2011/main" val="0"/>
             </a:ext>
           </a:extLst>
         </p:spPr>

</xml_diff>